<commit_message>
Update final report PDF (Final_Report.pdf) and presentation slide deck with live links, and align README
</commit_message>
<xml_diff>
--- a/reports/presentation.pptx
+++ b/reports/presentation.pptx
@@ -25,6 +25,7 @@
     <p:sldId id="273" r:id="rId19"/>
     <p:sldId id="274" r:id="rId20"/>
     <p:sldId id="275" r:id="rId21"/>
+    <p:sldId id="276" r:id="rId22"/>
   </p:sldIdLst>
   <p:sldSz cx="9144000" cy="5143500" type="screen16x9"/>
   <p:notesSz cx="6858000" cy="9144000"/>
@@ -321,7 +322,7 @@
           <a:p>
             <a:fld id="{5BCAD085-E8A6-8845-BD4E-CB4CCA059FC4}" type="datetimeFigureOut">
               <a:rPr lang="en-US" smtClean="0"/>
-              <a:t>7/12/2026</a:t>
+              <a:t>7/13/2026</a:t>
             </a:fld>
             <a:endParaRPr lang="en-US"/>
           </a:p>
@@ -489,7 +490,7 @@
           <a:p>
             <a:fld id="{5BCAD085-E8A6-8845-BD4E-CB4CCA059FC4}" type="datetimeFigureOut">
               <a:rPr lang="en-US" smtClean="0"/>
-              <a:t>7/12/2026</a:t>
+              <a:t>7/13/2026</a:t>
             </a:fld>
             <a:endParaRPr lang="en-US"/>
           </a:p>
@@ -667,7 +668,7 @@
           <a:p>
             <a:fld id="{5BCAD085-E8A6-8845-BD4E-CB4CCA059FC4}" type="datetimeFigureOut">
               <a:rPr lang="en-US" smtClean="0"/>
-              <a:t>7/12/2026</a:t>
+              <a:t>7/13/2026</a:t>
             </a:fld>
             <a:endParaRPr lang="en-US"/>
           </a:p>
@@ -835,7 +836,7 @@
           <a:p>
             <a:fld id="{5BCAD085-E8A6-8845-BD4E-CB4CCA059FC4}" type="datetimeFigureOut">
               <a:rPr lang="en-US" smtClean="0"/>
-              <a:t>7/12/2026</a:t>
+              <a:t>7/13/2026</a:t>
             </a:fld>
             <a:endParaRPr lang="en-US"/>
           </a:p>
@@ -1080,7 +1081,7 @@
           <a:p>
             <a:fld id="{5BCAD085-E8A6-8845-BD4E-CB4CCA059FC4}" type="datetimeFigureOut">
               <a:rPr lang="en-US" smtClean="0"/>
-              <a:t>7/12/2026</a:t>
+              <a:t>7/13/2026</a:t>
             </a:fld>
             <a:endParaRPr lang="en-US"/>
           </a:p>
@@ -1365,7 +1366,7 @@
           <a:p>
             <a:fld id="{5BCAD085-E8A6-8845-BD4E-CB4CCA059FC4}" type="datetimeFigureOut">
               <a:rPr lang="en-US" smtClean="0"/>
-              <a:t>7/12/2026</a:t>
+              <a:t>7/13/2026</a:t>
             </a:fld>
             <a:endParaRPr lang="en-US"/>
           </a:p>
@@ -1784,7 +1785,7 @@
           <a:p>
             <a:fld id="{5BCAD085-E8A6-8845-BD4E-CB4CCA059FC4}" type="datetimeFigureOut">
               <a:rPr lang="en-US" smtClean="0"/>
-              <a:t>7/12/2026</a:t>
+              <a:t>7/13/2026</a:t>
             </a:fld>
             <a:endParaRPr lang="en-US"/>
           </a:p>
@@ -1901,7 +1902,7 @@
           <a:p>
             <a:fld id="{5BCAD085-E8A6-8845-BD4E-CB4CCA059FC4}" type="datetimeFigureOut">
               <a:rPr lang="en-US" smtClean="0"/>
-              <a:t>7/12/2026</a:t>
+              <a:t>7/13/2026</a:t>
             </a:fld>
             <a:endParaRPr lang="en-US"/>
           </a:p>
@@ -1996,7 +1997,7 @@
           <a:p>
             <a:fld id="{5BCAD085-E8A6-8845-BD4E-CB4CCA059FC4}" type="datetimeFigureOut">
               <a:rPr lang="en-US" smtClean="0"/>
-              <a:t>7/12/2026</a:t>
+              <a:t>7/13/2026</a:t>
             </a:fld>
             <a:endParaRPr lang="en-US"/>
           </a:p>
@@ -2271,7 +2272,7 @@
           <a:p>
             <a:fld id="{5BCAD085-E8A6-8845-BD4E-CB4CCA059FC4}" type="datetimeFigureOut">
               <a:rPr lang="en-US" smtClean="0"/>
-              <a:t>7/12/2026</a:t>
+              <a:t>7/13/2026</a:t>
             </a:fld>
             <a:endParaRPr lang="en-US"/>
           </a:p>
@@ -2523,7 +2524,7 @@
           <a:p>
             <a:fld id="{5BCAD085-E8A6-8845-BD4E-CB4CCA059FC4}" type="datetimeFigureOut">
               <a:rPr lang="en-US" smtClean="0"/>
-              <a:t>7/12/2026</a:t>
+              <a:t>7/13/2026</a:t>
             </a:fld>
             <a:endParaRPr lang="en-US"/>
           </a:p>
@@ -2734,7 +2735,7 @@
           <a:p>
             <a:fld id="{5BCAD085-E8A6-8845-BD4E-CB4CCA059FC4}" type="datetimeFigureOut">
               <a:rPr lang="en-US" smtClean="0"/>
-              <a:t>7/12/2026</a:t>
+              <a:t>7/13/2026</a:t>
             </a:fld>
             <a:endParaRPr lang="en-US"/>
           </a:p>
@@ -9590,6 +9591,174 @@
         </p:txBody>
       </p:sp>
     </p:spTree>
+  </p:cSld>
+  <p:clrMapOvr>
+    <a:masterClrMapping/>
+  </p:clrMapOvr>
+</p:sld>
+</file>
+
+<file path=ppt/slides/slide21.xml><?xml version="1.0" encoding="utf-8"?>
+<p:sld xmlns:a="http://schemas.openxmlformats.org/drawingml/2006/main" xmlns:r="http://schemas.openxmlformats.org/officeDocument/2006/relationships" xmlns:p="http://schemas.openxmlformats.org/presentationml/2006/main">
+  <p:cSld>
+    <p:bg>
+      <p:bgPr>
+        <a:gradFill>
+          <a:gsLst>
+            <a:gs pos="0">
+              <a:schemeClr val="accent1">
+                <a:lumMod val="5000"/>
+                <a:lumOff val="95000"/>
+              </a:schemeClr>
+            </a:gs>
+            <a:gs pos="74000">
+              <a:schemeClr val="accent1">
+                <a:lumMod val="45000"/>
+                <a:lumOff val="55000"/>
+              </a:schemeClr>
+            </a:gs>
+            <a:gs pos="83000">
+              <a:schemeClr val="accent1">
+                <a:lumMod val="45000"/>
+                <a:lumOff val="55000"/>
+              </a:schemeClr>
+            </a:gs>
+            <a:gs pos="100000">
+              <a:schemeClr val="accent1">
+                <a:lumMod val="30000"/>
+                <a:lumOff val="70000"/>
+              </a:schemeClr>
+            </a:gs>
+          </a:gsLst>
+          <a:lin ang="5400000" scaled="1"/>
+        </a:gradFill>
+        <a:effectLst/>
+      </p:bgPr>
+    </p:bg>
+    <p:spTree>
+      <p:nvGrpSpPr>
+        <p:cNvPr id="1" name=""/>
+        <p:cNvGrpSpPr/>
+        <p:nvPr/>
+      </p:nvGrpSpPr>
+      <p:grpSpPr>
+        <a:xfrm>
+          <a:off x="0" y="0"/>
+          <a:ext cx="0" cy="0"/>
+          <a:chOff x="0" y="0"/>
+          <a:chExt cx="0" cy="0"/>
+        </a:xfrm>
+      </p:grpSpPr>
+      <p:sp>
+        <p:nvSpPr>
+          <p:cNvPr id="2" name="TextBox 1">
+            <a:extLst>
+              <a:ext uri="{FF2B5EF4-FFF2-40B4-BE49-F238E27FC236}">
+                <a16:creationId xmlns:a16="http://schemas.microsoft.com/office/drawing/2014/main" id="{F4C1F36E-15B1-3D5A-D0C2-B29651FA9FAB}"/>
+              </a:ext>
+            </a:extLst>
+          </p:cNvPr>
+          <p:cNvSpPr txBox="1"/>
+          <p:nvPr/>
+        </p:nvSpPr>
+        <p:spPr>
+          <a:xfrm>
+            <a:off x="445376" y="835572"/>
+            <a:ext cx="8253247" cy="3416320"/>
+          </a:xfrm>
+          <a:prstGeom prst="rect">
+            <a:avLst/>
+          </a:prstGeom>
+          <a:noFill/>
+        </p:spPr>
+        <p:txBody>
+          <a:bodyPr wrap="square" rtlCol="0">
+            <a:spAutoFit/>
+          </a:bodyPr>
+          <a:lstStyle/>
+          <a:p>
+            <a:r>
+              <a:rPr lang="en-US" b="1">
+                <a:latin typeface="Times New Roman" panose="02020603050405020304" pitchFamily="18" charset="0"/>
+                <a:cs typeface="Times New Roman" panose="02020603050405020304" pitchFamily="18" charset="0"/>
+              </a:rPr>
+              <a:t>Live link-</a:t>
+            </a:r>
+            <a:r>
+              <a:rPr lang="en-US" b="1" u="sng">
+                <a:latin typeface="Times New Roman" panose="02020603050405020304" pitchFamily="18" charset="0"/>
+                <a:cs typeface="Times New Roman" panose="02020603050405020304" pitchFamily="18" charset="0"/>
+                <a:hlinkClick r:id="rId2"/>
+              </a:rPr>
+              <a:t>https://bluestock-mf-analytics.streamlit.app/</a:t>
+            </a:r>
+            <a:endParaRPr lang="en-US" b="1" u="sng">
+              <a:latin typeface="Times New Roman" panose="02020603050405020304" pitchFamily="18" charset="0"/>
+              <a:cs typeface="Times New Roman" panose="02020603050405020304" pitchFamily="18" charset="0"/>
+            </a:endParaRPr>
+          </a:p>
+          <a:p>
+            <a:endParaRPr lang="en-US" b="1" u="sng">
+              <a:latin typeface="Times New Roman" panose="02020603050405020304" pitchFamily="18" charset="0"/>
+              <a:cs typeface="Times New Roman" panose="02020603050405020304" pitchFamily="18" charset="0"/>
+            </a:endParaRPr>
+          </a:p>
+          <a:p>
+            <a:endParaRPr lang="en-IN">
+              <a:latin typeface="Times New Roman" panose="02020603050405020304" pitchFamily="18" charset="0"/>
+              <a:cs typeface="Times New Roman" panose="02020603050405020304" pitchFamily="18" charset="0"/>
+            </a:endParaRPr>
+          </a:p>
+          <a:p>
+            <a:r>
+              <a:rPr lang="en-US">
+                <a:latin typeface="Times New Roman" panose="02020603050405020304" pitchFamily="18" charset="0"/>
+                <a:cs typeface="Times New Roman" panose="02020603050405020304" pitchFamily="18" charset="0"/>
+              </a:rPr>
+              <a:t> </a:t>
+            </a:r>
+            <a:r>
+              <a:rPr lang="en-US" b="1">
+                <a:latin typeface="Times New Roman" panose="02020603050405020304" pitchFamily="18" charset="0"/>
+                <a:cs typeface="Times New Roman" panose="02020603050405020304" pitchFamily="18" charset="0"/>
+              </a:rPr>
+              <a:t>Note:</a:t>
+            </a:r>
+            <a:r>
+              <a:rPr lang="en-US">
+                <a:latin typeface="Times New Roman" panose="02020603050405020304" pitchFamily="18" charset="0"/>
+                <a:cs typeface="Times New Roman" panose="02020603050405020304" pitchFamily="18" charset="0"/>
+              </a:rPr>
+              <a:t> </a:t>
+            </a:r>
+          </a:p>
+          <a:p>
+            <a:endParaRPr lang="en-US">
+              <a:latin typeface="Times New Roman" panose="02020603050405020304" pitchFamily="18" charset="0"/>
+              <a:cs typeface="Times New Roman" panose="02020603050405020304" pitchFamily="18" charset="0"/>
+            </a:endParaRPr>
+          </a:p>
+          <a:p>
+            <a:r>
+              <a:rPr lang="en-US">
+                <a:latin typeface="Times New Roman" panose="02020603050405020304" pitchFamily="18" charset="0"/>
+                <a:cs typeface="Times New Roman" panose="02020603050405020304" pitchFamily="18" charset="0"/>
+              </a:rPr>
+              <a:t>I scheduled my local ETL pipeline to run automatically every day at 8:00 PM on my computer. However, this only updates the database file locally on my machine. Since the live website reads the database file hosted on my GitHub repository (and Streamlit Cloud servers reset periodically), I must push the updated local database to GitHub to show the daily 8:00 PM updates on the live website. I have to push it manually every time because my local computer is isolated from the cloud, and the Streamlit Cloud server has no direct access to read files from my local system.</a:t>
+            </a:r>
+            <a:endParaRPr lang="en-IN">
+              <a:latin typeface="Times New Roman" panose="02020603050405020304" pitchFamily="18" charset="0"/>
+              <a:cs typeface="Times New Roman" panose="02020603050405020304" pitchFamily="18" charset="0"/>
+            </a:endParaRPr>
+          </a:p>
+        </p:txBody>
+      </p:sp>
+    </p:spTree>
+    <p:extLst>
+      <p:ext uri="{BB962C8B-B14F-4D97-AF65-F5344CB8AC3E}">
+        <p14:creationId xmlns:p14="http://schemas.microsoft.com/office/powerpoint/2010/main" val="1929464108"/>
+      </p:ext>
+    </p:extLst>
   </p:cSld>
   <p:clrMapOvr>
     <a:masterClrMapping/>

</xml_diff>

<commit_message>
docs: save presentation pptx progress
</commit_message>
<xml_diff>
--- a/reports/presentation.pptx
+++ b/reports/presentation.pptx
@@ -13,10 +13,10 @@
     <p:sldId id="258" r:id="rId4"/>
     <p:sldId id="259" r:id="rId5"/>
     <p:sldId id="260" r:id="rId6"/>
-    <p:sldId id="261" r:id="rId7"/>
-    <p:sldId id="277" r:id="rId8"/>
-    <p:sldId id="278" r:id="rId9"/>
-    <p:sldId id="279" r:id="rId10"/>
+    <p:sldId id="277" r:id="rId7"/>
+    <p:sldId id="278" r:id="rId8"/>
+    <p:sldId id="279" r:id="rId9"/>
+    <p:sldId id="261" r:id="rId10"/>
     <p:sldId id="262" r:id="rId11"/>
     <p:sldId id="263" r:id="rId12"/>
     <p:sldId id="264" r:id="rId13"/>
@@ -564,7 +564,7 @@
           <a:p>
             <a:fld id="{F7021451-1387-4CA6-816F-3879F97B5CBC}" type="slidenum">
               <a:rPr lang="en-US"/>
-              <a:t>8</a:t>
+              <a:t>7</a:t>
             </a:fld>
             <a:endParaRPr lang="en-US"/>
           </a:p>
@@ -648,7 +648,7 @@
           <a:p>
             <a:fld id="{F7021451-1387-4CA6-816F-3879F97B5CBC}" type="slidenum">
               <a:rPr lang="en-US"/>
-              <a:t>9</a:t>
+              <a:t>8</a:t>
             </a:fld>
             <a:endParaRPr lang="en-US"/>
           </a:p>
@@ -14213,1212 +14213,6 @@
           <a:chExt cx="0" cy="0"/>
         </a:xfrm>
       </p:grpSpPr>
-      <p:sp>
-        <p:nvSpPr>
-          <p:cNvPr id="2" name="Rectangle 1"/>
-          <p:cNvSpPr/>
-          <p:nvPr/>
-        </p:nvSpPr>
-        <p:spPr>
-          <a:xfrm>
-            <a:off x="0" y="0"/>
-            <a:ext cx="9144000" cy="5143500"/>
-          </a:xfrm>
-          <a:prstGeom prst="rect">
-            <a:avLst/>
-          </a:prstGeom>
-          <a:solidFill>
-            <a:srgbClr val="F8FAFC"/>
-          </a:solidFill>
-          <a:ln>
-            <a:noFill/>
-          </a:ln>
-          <a:effectLst/>
-        </p:spPr>
-        <p:style>
-          <a:lnRef idx="1">
-            <a:schemeClr val="accent1"/>
-          </a:lnRef>
-          <a:fillRef idx="3">
-            <a:schemeClr val="accent1"/>
-          </a:fillRef>
-          <a:effectRef idx="2">
-            <a:schemeClr val="accent1"/>
-          </a:effectRef>
-          <a:fontRef idx="minor">
-            <a:schemeClr val="lt1"/>
-          </a:fontRef>
-        </p:style>
-        <p:txBody>
-          <a:bodyPr rtlCol="0" anchor="ctr"/>
-          <a:lstStyle/>
-          <a:p>
-            <a:pPr algn="ctr"/>
-            <a:endParaRPr>
-              <a:latin typeface="Times New Roman" panose="02020603050405020304" pitchFamily="18" charset="0"/>
-              <a:cs typeface="Times New Roman" panose="02020603050405020304" pitchFamily="18" charset="0"/>
-            </a:endParaRPr>
-          </a:p>
-        </p:txBody>
-      </p:sp>
-      <p:sp>
-        <p:nvSpPr>
-          <p:cNvPr id="3" name="TextBox 2"/>
-          <p:cNvSpPr txBox="1"/>
-          <p:nvPr/>
-        </p:nvSpPr>
-        <p:spPr>
-          <a:xfrm>
-            <a:off x="457200" y="320040"/>
-            <a:ext cx="5486400" cy="169277"/>
-          </a:xfrm>
-          <a:prstGeom prst="rect">
-            <a:avLst/>
-          </a:prstGeom>
-          <a:noFill/>
-        </p:spPr>
-        <p:txBody>
-          <a:bodyPr wrap="square" lIns="0" tIns="0" rIns="0" bIns="0" anchor="t">
-            <a:spAutoFit/>
-          </a:bodyPr>
-          <a:lstStyle/>
-          <a:p>
-            <a:r>
-              <a:rPr sz="1100" b="1" i="0" spc="150">
-                <a:solidFill>
-                  <a:srgbClr val="F58220"/>
-                </a:solidFill>
-                <a:latin typeface="Times New Roman" panose="02020603050405020304" pitchFamily="18" charset="0"/>
-                <a:cs typeface="Times New Roman" panose="02020603050405020304" pitchFamily="18" charset="0"/>
-              </a:rPr>
-              <a:t>ARCHITECTURE</a:t>
-            </a:r>
-          </a:p>
-        </p:txBody>
-      </p:sp>
-      <p:sp>
-        <p:nvSpPr>
-          <p:cNvPr id="4" name="TextBox 3"/>
-          <p:cNvSpPr txBox="1"/>
-          <p:nvPr/>
-        </p:nvSpPr>
-        <p:spPr>
-          <a:xfrm>
-            <a:off x="457200" y="566928"/>
-            <a:ext cx="8229600" cy="369332"/>
-          </a:xfrm>
-          <a:prstGeom prst="rect">
-            <a:avLst/>
-          </a:prstGeom>
-          <a:noFill/>
-        </p:spPr>
-        <p:txBody>
-          <a:bodyPr wrap="square" lIns="0" tIns="0" rIns="0" bIns="0" anchor="t">
-            <a:spAutoFit/>
-          </a:bodyPr>
-          <a:lstStyle/>
-          <a:p>
-            <a:r>
-              <a:rPr sz="2400" b="1" i="0">
-                <a:solidFill>
-                  <a:srgbClr val="0C1E36"/>
-                </a:solidFill>
-                <a:latin typeface="Times New Roman" panose="02020603050405020304" pitchFamily="18" charset="0"/>
-                <a:cs typeface="Times New Roman" panose="02020603050405020304" pitchFamily="18" charset="0"/>
-              </a:rPr>
-              <a:t>Database Design &amp; ETL Pipeline</a:t>
-            </a:r>
-          </a:p>
-        </p:txBody>
-      </p:sp>
-      <p:sp>
-        <p:nvSpPr>
-          <p:cNvPr id="5" name="TextBox 4"/>
-          <p:cNvSpPr txBox="1"/>
-          <p:nvPr/>
-        </p:nvSpPr>
-        <p:spPr>
-          <a:xfrm>
-            <a:off x="457200" y="1191062"/>
-            <a:ext cx="3931920" cy="200055"/>
-          </a:xfrm>
-          <a:prstGeom prst="rect">
-            <a:avLst/>
-          </a:prstGeom>
-          <a:noFill/>
-        </p:spPr>
-        <p:txBody>
-          <a:bodyPr wrap="square" lIns="0" tIns="0" rIns="0" bIns="0" anchor="t">
-            <a:spAutoFit/>
-          </a:bodyPr>
-          <a:lstStyle/>
-          <a:p>
-            <a:r>
-              <a:rPr sz="1300" b="1" i="0">
-                <a:solidFill>
-                  <a:srgbClr val="0C1E36"/>
-                </a:solidFill>
-                <a:latin typeface="Times New Roman" panose="02020603050405020304" pitchFamily="18" charset="0"/>
-                <a:cs typeface="Times New Roman" panose="02020603050405020304" pitchFamily="18" charset="0"/>
-              </a:rPr>
-              <a:t>Star-Schema Tables</a:t>
-            </a:r>
-          </a:p>
-        </p:txBody>
-      </p:sp>
-      <p:sp>
-        <p:nvSpPr>
-          <p:cNvPr id="6" name="TextBox 5"/>
-          <p:cNvSpPr txBox="1"/>
-          <p:nvPr/>
-        </p:nvSpPr>
-        <p:spPr>
-          <a:xfrm>
-            <a:off x="457200" y="1560852"/>
-            <a:ext cx="3931920" cy="359073"/>
-          </a:xfrm>
-          <a:prstGeom prst="rect">
-            <a:avLst/>
-          </a:prstGeom>
-          <a:noFill/>
-        </p:spPr>
-        <p:txBody>
-          <a:bodyPr wrap="square" lIns="0" tIns="0" rIns="0" bIns="0" anchor="t">
-            <a:spAutoFit/>
-          </a:bodyPr>
-          <a:lstStyle/>
-          <a:p>
-            <a:r>
-              <a:rPr sz="1200" b="1" i="0">
-                <a:solidFill>
-                  <a:srgbClr val="F58220"/>
-                </a:solidFill>
-                <a:latin typeface="Times New Roman" panose="02020603050405020304" pitchFamily="18" charset="0"/>
-                <a:cs typeface="Times New Roman" panose="02020603050405020304" pitchFamily="18" charset="0"/>
-              </a:rPr>
-              <a:t>dim_fund</a:t>
-            </a:r>
-          </a:p>
-          <a:p>
-            <a:pPr>
-              <a:spcBef>
-                <a:spcPts val="100"/>
-              </a:spcBef>
-            </a:pPr>
-            <a:r>
-              <a:rPr sz="1050" b="0" i="0">
-                <a:solidFill>
-                  <a:srgbClr val="333333"/>
-                </a:solidFill>
-                <a:latin typeface="Times New Roman" panose="02020603050405020304" pitchFamily="18" charset="0"/>
-                <a:cs typeface="Times New Roman" panose="02020603050405020304" pitchFamily="18" charset="0"/>
-              </a:rPr>
-              <a:t>fund_id, amfi_code, scheme_name, category, risk_category, benchmark</a:t>
-            </a:r>
-          </a:p>
-        </p:txBody>
-      </p:sp>
-      <p:sp>
-        <p:nvSpPr>
-          <p:cNvPr id="7" name="TextBox 6"/>
-          <p:cNvSpPr txBox="1"/>
-          <p:nvPr/>
-        </p:nvSpPr>
-        <p:spPr>
-          <a:xfrm>
-            <a:off x="457200" y="2143012"/>
-            <a:ext cx="3931920" cy="359073"/>
-          </a:xfrm>
-          <a:prstGeom prst="rect">
-            <a:avLst/>
-          </a:prstGeom>
-          <a:noFill/>
-        </p:spPr>
-        <p:txBody>
-          <a:bodyPr wrap="square" lIns="0" tIns="0" rIns="0" bIns="0" anchor="t">
-            <a:spAutoFit/>
-          </a:bodyPr>
-          <a:lstStyle/>
-          <a:p>
-            <a:r>
-              <a:rPr sz="1200" b="1" i="0">
-                <a:solidFill>
-                  <a:srgbClr val="F58220"/>
-                </a:solidFill>
-                <a:latin typeface="Times New Roman" panose="02020603050405020304" pitchFamily="18" charset="0"/>
-                <a:cs typeface="Times New Roman" panose="02020603050405020304" pitchFamily="18" charset="0"/>
-              </a:rPr>
-              <a:t>dim_date</a:t>
-            </a:r>
-          </a:p>
-          <a:p>
-            <a:pPr>
-              <a:spcBef>
-                <a:spcPts val="100"/>
-              </a:spcBef>
-            </a:pPr>
-            <a:r>
-              <a:rPr sz="1050" b="0" i="0">
-                <a:solidFill>
-                  <a:srgbClr val="333333"/>
-                </a:solidFill>
-                <a:latin typeface="Times New Roman" panose="02020603050405020304" pitchFamily="18" charset="0"/>
-                <a:cs typeface="Times New Roman" panose="02020603050405020304" pitchFamily="18" charset="0"/>
-              </a:rPr>
-              <a:t>date_id, full_date, month, year, quarter</a:t>
-            </a:r>
-          </a:p>
-        </p:txBody>
-      </p:sp>
-      <p:sp>
-        <p:nvSpPr>
-          <p:cNvPr id="8" name="TextBox 7"/>
-          <p:cNvSpPr txBox="1"/>
-          <p:nvPr/>
-        </p:nvSpPr>
-        <p:spPr>
-          <a:xfrm>
-            <a:off x="457200" y="2685879"/>
-            <a:ext cx="3931920" cy="359073"/>
-          </a:xfrm>
-          <a:prstGeom prst="rect">
-            <a:avLst/>
-          </a:prstGeom>
-          <a:noFill/>
-        </p:spPr>
-        <p:txBody>
-          <a:bodyPr wrap="square" lIns="0" tIns="0" rIns="0" bIns="0" anchor="t">
-            <a:spAutoFit/>
-          </a:bodyPr>
-          <a:lstStyle/>
-          <a:p>
-            <a:r>
-              <a:rPr sz="1200" b="1" i="0">
-                <a:solidFill>
-                  <a:srgbClr val="F58220"/>
-                </a:solidFill>
-                <a:latin typeface="Times New Roman" panose="02020603050405020304" pitchFamily="18" charset="0"/>
-                <a:cs typeface="Times New Roman" panose="02020603050405020304" pitchFamily="18" charset="0"/>
-              </a:rPr>
-              <a:t>fact_nav</a:t>
-            </a:r>
-          </a:p>
-          <a:p>
-            <a:pPr>
-              <a:spcBef>
-                <a:spcPts val="100"/>
-              </a:spcBef>
-            </a:pPr>
-            <a:r>
-              <a:rPr sz="1050" b="0" i="0">
-                <a:solidFill>
-                  <a:srgbClr val="333333"/>
-                </a:solidFill>
-                <a:latin typeface="Times New Roman" panose="02020603050405020304" pitchFamily="18" charset="0"/>
-                <a:cs typeface="Times New Roman" panose="02020603050405020304" pitchFamily="18" charset="0"/>
-              </a:rPr>
-              <a:t>nav_id, fund_id (FK), date_id (FK), nav</a:t>
-            </a:r>
-          </a:p>
-        </p:txBody>
-      </p:sp>
-      <p:sp>
-        <p:nvSpPr>
-          <p:cNvPr id="9" name="TextBox 8"/>
-          <p:cNvSpPr txBox="1"/>
-          <p:nvPr/>
-        </p:nvSpPr>
-        <p:spPr>
-          <a:xfrm>
-            <a:off x="457200" y="3236379"/>
-            <a:ext cx="3931920" cy="359073"/>
-          </a:xfrm>
-          <a:prstGeom prst="rect">
-            <a:avLst/>
-          </a:prstGeom>
-          <a:noFill/>
-        </p:spPr>
-        <p:txBody>
-          <a:bodyPr wrap="square" lIns="0" tIns="0" rIns="0" bIns="0" anchor="t">
-            <a:spAutoFit/>
-          </a:bodyPr>
-          <a:lstStyle/>
-          <a:p>
-            <a:r>
-              <a:rPr sz="1200" b="1" i="0">
-                <a:solidFill>
-                  <a:srgbClr val="F58220"/>
-                </a:solidFill>
-                <a:latin typeface="Times New Roman" panose="02020603050405020304" pitchFamily="18" charset="0"/>
-                <a:cs typeface="Times New Roman" panose="02020603050405020304" pitchFamily="18" charset="0"/>
-              </a:rPr>
-              <a:t>fact_performance</a:t>
-            </a:r>
-          </a:p>
-          <a:p>
-            <a:pPr>
-              <a:spcBef>
-                <a:spcPts val="100"/>
-              </a:spcBef>
-            </a:pPr>
-            <a:r>
-              <a:rPr sz="1050" b="0" i="0">
-                <a:solidFill>
-                  <a:srgbClr val="333333"/>
-                </a:solidFill>
-                <a:latin typeface="Times New Roman" panose="02020603050405020304" pitchFamily="18" charset="0"/>
-                <a:cs typeface="Times New Roman" panose="02020603050405020304" pitchFamily="18" charset="0"/>
-              </a:rPr>
-              <a:t>return metrics, Sharpe/Sortino, alpha, beta, AUM, expense ratio</a:t>
-            </a:r>
-          </a:p>
-        </p:txBody>
-      </p:sp>
-      <p:sp>
-        <p:nvSpPr>
-          <p:cNvPr id="10" name="TextBox 9"/>
-          <p:cNvSpPr txBox="1"/>
-          <p:nvPr/>
-        </p:nvSpPr>
-        <p:spPr>
-          <a:xfrm>
-            <a:off x="457200" y="4314108"/>
-            <a:ext cx="3931920" cy="359073"/>
-          </a:xfrm>
-          <a:prstGeom prst="rect">
-            <a:avLst/>
-          </a:prstGeom>
-          <a:noFill/>
-        </p:spPr>
-        <p:txBody>
-          <a:bodyPr wrap="square" lIns="0" tIns="0" rIns="0" bIns="0" anchor="t">
-            <a:spAutoFit/>
-          </a:bodyPr>
-          <a:lstStyle/>
-          <a:p>
-            <a:r>
-              <a:rPr sz="1200" b="1" i="0">
-                <a:solidFill>
-                  <a:srgbClr val="F58220"/>
-                </a:solidFill>
-                <a:latin typeface="Times New Roman" panose="02020603050405020304" pitchFamily="18" charset="0"/>
-                <a:cs typeface="Times New Roman" panose="02020603050405020304" pitchFamily="18" charset="0"/>
-              </a:rPr>
-              <a:t>etl_metadata</a:t>
-            </a:r>
-          </a:p>
-          <a:p>
-            <a:pPr>
-              <a:spcBef>
-                <a:spcPts val="100"/>
-              </a:spcBef>
-            </a:pPr>
-            <a:r>
-              <a:rPr sz="1050" b="0" i="0">
-                <a:solidFill>
-                  <a:srgbClr val="333333"/>
-                </a:solidFill>
-                <a:latin typeface="Times New Roman" panose="02020603050405020304" pitchFamily="18" charset="0"/>
-                <a:cs typeface="Times New Roman" panose="02020603050405020304" pitchFamily="18" charset="0"/>
-              </a:rPr>
-              <a:t>logs run timestamps, status, row counts</a:t>
-            </a:r>
-          </a:p>
-        </p:txBody>
-      </p:sp>
-      <p:sp>
-        <p:nvSpPr>
-          <p:cNvPr id="11" name="TextBox 10"/>
-          <p:cNvSpPr txBox="1"/>
-          <p:nvPr/>
-        </p:nvSpPr>
-        <p:spPr>
-          <a:xfrm>
-            <a:off x="4709160" y="1325880"/>
-            <a:ext cx="3977639" cy="200055"/>
-          </a:xfrm>
-          <a:prstGeom prst="rect">
-            <a:avLst/>
-          </a:prstGeom>
-          <a:noFill/>
-        </p:spPr>
-        <p:txBody>
-          <a:bodyPr wrap="square" lIns="0" tIns="0" rIns="0" bIns="0" anchor="t">
-            <a:spAutoFit/>
-          </a:bodyPr>
-          <a:lstStyle/>
-          <a:p>
-            <a:r>
-              <a:rPr sz="1300" b="1" i="0">
-                <a:solidFill>
-                  <a:srgbClr val="0C1E36"/>
-                </a:solidFill>
-                <a:latin typeface="Times New Roman" panose="02020603050405020304" pitchFamily="18" charset="0"/>
-                <a:cs typeface="Times New Roman" panose="02020603050405020304" pitchFamily="18" charset="0"/>
-              </a:rPr>
-              <a:t>ETL Workflow</a:t>
-            </a:r>
-          </a:p>
-        </p:txBody>
-      </p:sp>
-      <p:sp>
-        <p:nvSpPr>
-          <p:cNvPr id="12" name="Oval 11"/>
-          <p:cNvSpPr/>
-          <p:nvPr/>
-        </p:nvSpPr>
-        <p:spPr>
-          <a:xfrm>
-            <a:off x="4709160" y="1709928"/>
-            <a:ext cx="201168" cy="201168"/>
-          </a:xfrm>
-          <a:prstGeom prst="ellipse">
-            <a:avLst/>
-          </a:prstGeom>
-          <a:solidFill>
-            <a:srgbClr val="0C1E36"/>
-          </a:solidFill>
-          <a:ln>
-            <a:noFill/>
-          </a:ln>
-          <a:effectLst/>
-        </p:spPr>
-        <p:style>
-          <a:lnRef idx="1">
-            <a:schemeClr val="accent1"/>
-          </a:lnRef>
-          <a:fillRef idx="3">
-            <a:schemeClr val="accent1"/>
-          </a:fillRef>
-          <a:effectRef idx="2">
-            <a:schemeClr val="accent1"/>
-          </a:effectRef>
-          <a:fontRef idx="minor">
-            <a:schemeClr val="lt1"/>
-          </a:fontRef>
-        </p:style>
-        <p:txBody>
-          <a:bodyPr lIns="0" tIns="0" rIns="0" bIns="0" rtlCol="0" anchor="ctr"/>
-          <a:lstStyle/>
-          <a:p>
-            <a:pPr algn="ctr"/>
-            <a:r>
-              <a:rPr sz="900" b="1" i="0">
-                <a:solidFill>
-                  <a:srgbClr val="FFFFFF"/>
-                </a:solidFill>
-                <a:latin typeface="Times New Roman" panose="02020603050405020304" pitchFamily="18" charset="0"/>
-                <a:cs typeface="Times New Roman" panose="02020603050405020304" pitchFamily="18" charset="0"/>
-              </a:rPr>
-              <a:t>1</a:t>
-            </a:r>
-          </a:p>
-        </p:txBody>
-      </p:sp>
-      <p:sp>
-        <p:nvSpPr>
-          <p:cNvPr id="13" name="TextBox 12"/>
-          <p:cNvSpPr txBox="1"/>
-          <p:nvPr/>
-        </p:nvSpPr>
-        <p:spPr>
-          <a:xfrm>
-            <a:off x="5047488" y="1664208"/>
-            <a:ext cx="3639312" cy="338554"/>
-          </a:xfrm>
-          <a:prstGeom prst="rect">
-            <a:avLst/>
-          </a:prstGeom>
-          <a:noFill/>
-        </p:spPr>
-        <p:txBody>
-          <a:bodyPr wrap="square" lIns="0" tIns="0" rIns="0" bIns="0" anchor="t">
-            <a:spAutoFit/>
-          </a:bodyPr>
-          <a:lstStyle/>
-          <a:p>
-            <a:r>
-              <a:rPr sz="1150" b="1" i="0">
-                <a:solidFill>
-                  <a:srgbClr val="0C1E36"/>
-                </a:solidFill>
-                <a:latin typeface="Times New Roman" panose="02020603050405020304" pitchFamily="18" charset="0"/>
-                <a:cs typeface="Times New Roman" panose="02020603050405020304" pitchFamily="18" charset="0"/>
-              </a:rPr>
-              <a:t>Extract  —  </a:t>
-            </a:r>
-            <a:r>
-              <a:rPr sz="1050" b="0" i="0">
-                <a:solidFill>
-                  <a:srgbClr val="333333"/>
-                </a:solidFill>
-                <a:latin typeface="Times New Roman" panose="02020603050405020304" pitchFamily="18" charset="0"/>
-                <a:cs typeface="Times New Roman" panose="02020603050405020304" pitchFamily="18" charset="0"/>
-              </a:rPr>
-              <a:t>Reads raw CSVs and queries AMFI / MFAPI APIs for live historical NAV data.</a:t>
-            </a:r>
-          </a:p>
-        </p:txBody>
-      </p:sp>
-      <p:sp>
-        <p:nvSpPr>
-          <p:cNvPr id="14" name="Oval 13"/>
-          <p:cNvSpPr/>
-          <p:nvPr/>
-        </p:nvSpPr>
-        <p:spPr>
-          <a:xfrm>
-            <a:off x="4709160" y="2276856"/>
-            <a:ext cx="201168" cy="201168"/>
-          </a:xfrm>
-          <a:prstGeom prst="ellipse">
-            <a:avLst/>
-          </a:prstGeom>
-          <a:solidFill>
-            <a:srgbClr val="0C1E36"/>
-          </a:solidFill>
-          <a:ln>
-            <a:noFill/>
-          </a:ln>
-          <a:effectLst/>
-        </p:spPr>
-        <p:style>
-          <a:lnRef idx="1">
-            <a:schemeClr val="accent1"/>
-          </a:lnRef>
-          <a:fillRef idx="3">
-            <a:schemeClr val="accent1"/>
-          </a:fillRef>
-          <a:effectRef idx="2">
-            <a:schemeClr val="accent1"/>
-          </a:effectRef>
-          <a:fontRef idx="minor">
-            <a:schemeClr val="lt1"/>
-          </a:fontRef>
-        </p:style>
-        <p:txBody>
-          <a:bodyPr lIns="0" tIns="0" rIns="0" bIns="0" rtlCol="0" anchor="ctr"/>
-          <a:lstStyle/>
-          <a:p>
-            <a:pPr algn="ctr"/>
-            <a:r>
-              <a:rPr sz="900" b="1" i="0">
-                <a:solidFill>
-                  <a:srgbClr val="FFFFFF"/>
-                </a:solidFill>
-                <a:latin typeface="Times New Roman" panose="02020603050405020304" pitchFamily="18" charset="0"/>
-                <a:cs typeface="Times New Roman" panose="02020603050405020304" pitchFamily="18" charset="0"/>
-              </a:rPr>
-              <a:t>2</a:t>
-            </a:r>
-          </a:p>
-        </p:txBody>
-      </p:sp>
-      <p:sp>
-        <p:nvSpPr>
-          <p:cNvPr id="15" name="TextBox 14"/>
-          <p:cNvSpPr txBox="1"/>
-          <p:nvPr/>
-        </p:nvSpPr>
-        <p:spPr>
-          <a:xfrm>
-            <a:off x="5047488" y="2231136"/>
-            <a:ext cx="3639312" cy="338554"/>
-          </a:xfrm>
-          <a:prstGeom prst="rect">
-            <a:avLst/>
-          </a:prstGeom>
-          <a:noFill/>
-        </p:spPr>
-        <p:txBody>
-          <a:bodyPr wrap="square" lIns="0" tIns="0" rIns="0" bIns="0" anchor="t">
-            <a:spAutoFit/>
-          </a:bodyPr>
-          <a:lstStyle/>
-          <a:p>
-            <a:r>
-              <a:rPr sz="1150" b="1" i="0">
-                <a:solidFill>
-                  <a:srgbClr val="0C1E36"/>
-                </a:solidFill>
-                <a:latin typeface="Times New Roman" panose="02020603050405020304" pitchFamily="18" charset="0"/>
-                <a:cs typeface="Times New Roman" panose="02020603050405020304" pitchFamily="18" charset="0"/>
-              </a:rPr>
-              <a:t>Transform  —  </a:t>
-            </a:r>
-            <a:r>
-              <a:rPr sz="1050" b="0" i="0">
-                <a:solidFill>
-                  <a:srgbClr val="333333"/>
-                </a:solidFill>
-                <a:latin typeface="Times New Roman" panose="02020603050405020304" pitchFamily="18" charset="0"/>
-                <a:cs typeface="Times New Roman" panose="02020603050405020304" pitchFamily="18" charset="0"/>
-              </a:rPr>
-              <a:t>Standardizes dates, coerces types, removes duplicates, handles missing values.</a:t>
-            </a:r>
-          </a:p>
-        </p:txBody>
-      </p:sp>
-      <p:sp>
-        <p:nvSpPr>
-          <p:cNvPr id="16" name="Oval 15"/>
-          <p:cNvSpPr/>
-          <p:nvPr/>
-        </p:nvSpPr>
-        <p:spPr>
-          <a:xfrm>
-            <a:off x="4709160" y="2843784"/>
-            <a:ext cx="201168" cy="201168"/>
-          </a:xfrm>
-          <a:prstGeom prst="ellipse">
-            <a:avLst/>
-          </a:prstGeom>
-          <a:solidFill>
-            <a:srgbClr val="0C1E36"/>
-          </a:solidFill>
-          <a:ln>
-            <a:noFill/>
-          </a:ln>
-          <a:effectLst/>
-        </p:spPr>
-        <p:style>
-          <a:lnRef idx="1">
-            <a:schemeClr val="accent1"/>
-          </a:lnRef>
-          <a:fillRef idx="3">
-            <a:schemeClr val="accent1"/>
-          </a:fillRef>
-          <a:effectRef idx="2">
-            <a:schemeClr val="accent1"/>
-          </a:effectRef>
-          <a:fontRef idx="minor">
-            <a:schemeClr val="lt1"/>
-          </a:fontRef>
-        </p:style>
-        <p:txBody>
-          <a:bodyPr lIns="0" tIns="0" rIns="0" bIns="0" rtlCol="0" anchor="ctr"/>
-          <a:lstStyle/>
-          <a:p>
-            <a:pPr algn="ctr"/>
-            <a:r>
-              <a:rPr sz="900" b="1" i="0">
-                <a:solidFill>
-                  <a:srgbClr val="FFFFFF"/>
-                </a:solidFill>
-                <a:latin typeface="Times New Roman" panose="02020603050405020304" pitchFamily="18" charset="0"/>
-                <a:cs typeface="Times New Roman" panose="02020603050405020304" pitchFamily="18" charset="0"/>
-              </a:rPr>
-              <a:t>3</a:t>
-            </a:r>
-          </a:p>
-        </p:txBody>
-      </p:sp>
-      <p:sp>
-        <p:nvSpPr>
-          <p:cNvPr id="17" name="TextBox 16"/>
-          <p:cNvSpPr txBox="1"/>
-          <p:nvPr/>
-        </p:nvSpPr>
-        <p:spPr>
-          <a:xfrm>
-            <a:off x="5047488" y="2798064"/>
-            <a:ext cx="3639312" cy="338554"/>
-          </a:xfrm>
-          <a:prstGeom prst="rect">
-            <a:avLst/>
-          </a:prstGeom>
-          <a:noFill/>
-        </p:spPr>
-        <p:txBody>
-          <a:bodyPr wrap="square" lIns="0" tIns="0" rIns="0" bIns="0" anchor="t">
-            <a:spAutoFit/>
-          </a:bodyPr>
-          <a:lstStyle/>
-          <a:p>
-            <a:r>
-              <a:rPr sz="1150" b="1" i="0">
-                <a:solidFill>
-                  <a:srgbClr val="0C1E36"/>
-                </a:solidFill>
-                <a:latin typeface="Times New Roman" panose="02020603050405020304" pitchFamily="18" charset="0"/>
-                <a:cs typeface="Times New Roman" panose="02020603050405020304" pitchFamily="18" charset="0"/>
-              </a:rPr>
-              <a:t>Correct  —  </a:t>
-            </a:r>
-            <a:r>
-              <a:rPr sz="1050" b="0" i="0">
-                <a:solidFill>
-                  <a:srgbClr val="333333"/>
-                </a:solidFill>
-                <a:latin typeface="Times New Roman" panose="02020603050405020304" pitchFamily="18" charset="0"/>
-                <a:cs typeface="Times New Roman" panose="02020603050405020304" pitchFamily="18" charset="0"/>
-              </a:rPr>
-              <a:t>Fixes AMFI ID mismatches (e.g. ABSL Large Cap 112114 → 103174).</a:t>
-            </a:r>
-          </a:p>
-        </p:txBody>
-      </p:sp>
-      <p:sp>
-        <p:nvSpPr>
-          <p:cNvPr id="18" name="Oval 17"/>
-          <p:cNvSpPr/>
-          <p:nvPr/>
-        </p:nvSpPr>
-        <p:spPr>
-          <a:xfrm>
-            <a:off x="4709160" y="3410712"/>
-            <a:ext cx="201168" cy="201168"/>
-          </a:xfrm>
-          <a:prstGeom prst="ellipse">
-            <a:avLst/>
-          </a:prstGeom>
-          <a:solidFill>
-            <a:srgbClr val="0C1E36"/>
-          </a:solidFill>
-          <a:ln>
-            <a:noFill/>
-          </a:ln>
-          <a:effectLst/>
-        </p:spPr>
-        <p:style>
-          <a:lnRef idx="1">
-            <a:schemeClr val="accent1"/>
-          </a:lnRef>
-          <a:fillRef idx="3">
-            <a:schemeClr val="accent1"/>
-          </a:fillRef>
-          <a:effectRef idx="2">
-            <a:schemeClr val="accent1"/>
-          </a:effectRef>
-          <a:fontRef idx="minor">
-            <a:schemeClr val="lt1"/>
-          </a:fontRef>
-        </p:style>
-        <p:txBody>
-          <a:bodyPr lIns="0" tIns="0" rIns="0" bIns="0" rtlCol="0" anchor="ctr"/>
-          <a:lstStyle/>
-          <a:p>
-            <a:pPr algn="ctr"/>
-            <a:r>
-              <a:rPr sz="900" b="1" i="0">
-                <a:solidFill>
-                  <a:srgbClr val="FFFFFF"/>
-                </a:solidFill>
-                <a:latin typeface="Times New Roman" panose="02020603050405020304" pitchFamily="18" charset="0"/>
-                <a:cs typeface="Times New Roman" panose="02020603050405020304" pitchFamily="18" charset="0"/>
-              </a:rPr>
-              <a:t>4</a:t>
-            </a:r>
-          </a:p>
-        </p:txBody>
-      </p:sp>
-      <p:sp>
-        <p:nvSpPr>
-          <p:cNvPr id="19" name="TextBox 18"/>
-          <p:cNvSpPr txBox="1"/>
-          <p:nvPr/>
-        </p:nvSpPr>
-        <p:spPr>
-          <a:xfrm>
-            <a:off x="5047488" y="3364992"/>
-            <a:ext cx="3639312" cy="338554"/>
-          </a:xfrm>
-          <a:prstGeom prst="rect">
-            <a:avLst/>
-          </a:prstGeom>
-          <a:noFill/>
-        </p:spPr>
-        <p:txBody>
-          <a:bodyPr wrap="square" lIns="0" tIns="0" rIns="0" bIns="0" anchor="t">
-            <a:spAutoFit/>
-          </a:bodyPr>
-          <a:lstStyle/>
-          <a:p>
-            <a:r>
-              <a:rPr sz="1150" b="1" i="0">
-                <a:solidFill>
-                  <a:srgbClr val="0C1E36"/>
-                </a:solidFill>
-                <a:latin typeface="Times New Roman" panose="02020603050405020304" pitchFamily="18" charset="0"/>
-                <a:cs typeface="Times New Roman" panose="02020603050405020304" pitchFamily="18" charset="0"/>
-              </a:rPr>
-              <a:t>Load  —  </a:t>
-            </a:r>
-            <a:r>
-              <a:rPr sz="1050" b="0" i="0">
-                <a:solidFill>
-                  <a:srgbClr val="333333"/>
-                </a:solidFill>
-                <a:latin typeface="Times New Roman" panose="02020603050405020304" pitchFamily="18" charset="0"/>
-                <a:cs typeface="Times New Roman" panose="02020603050405020304" pitchFamily="18" charset="0"/>
-              </a:rPr>
-              <a:t>Loads cleaned staging tables into SQLite with FK &amp; unique constraints.</a:t>
-            </a:r>
-          </a:p>
-        </p:txBody>
-      </p:sp>
-      <p:sp>
-        <p:nvSpPr>
-          <p:cNvPr id="20" name="Oval 19"/>
-          <p:cNvSpPr/>
-          <p:nvPr/>
-        </p:nvSpPr>
-        <p:spPr>
-          <a:xfrm>
-            <a:off x="4709160" y="3977640"/>
-            <a:ext cx="201168" cy="201168"/>
-          </a:xfrm>
-          <a:prstGeom prst="ellipse">
-            <a:avLst/>
-          </a:prstGeom>
-          <a:solidFill>
-            <a:srgbClr val="0C1E36"/>
-          </a:solidFill>
-          <a:ln>
-            <a:noFill/>
-          </a:ln>
-          <a:effectLst/>
-        </p:spPr>
-        <p:style>
-          <a:lnRef idx="1">
-            <a:schemeClr val="accent1"/>
-          </a:lnRef>
-          <a:fillRef idx="3">
-            <a:schemeClr val="accent1"/>
-          </a:fillRef>
-          <a:effectRef idx="2">
-            <a:schemeClr val="accent1"/>
-          </a:effectRef>
-          <a:fontRef idx="minor">
-            <a:schemeClr val="lt1"/>
-          </a:fontRef>
-        </p:style>
-        <p:txBody>
-          <a:bodyPr lIns="0" tIns="0" rIns="0" bIns="0" rtlCol="0" anchor="ctr"/>
-          <a:lstStyle/>
-          <a:p>
-            <a:pPr algn="ctr"/>
-            <a:r>
-              <a:rPr sz="900" b="1" i="0">
-                <a:solidFill>
-                  <a:srgbClr val="FFFFFF"/>
-                </a:solidFill>
-                <a:latin typeface="Times New Roman" panose="02020603050405020304" pitchFamily="18" charset="0"/>
-                <a:cs typeface="Times New Roman" panose="02020603050405020304" pitchFamily="18" charset="0"/>
-              </a:rPr>
-              <a:t>5</a:t>
-            </a:r>
-          </a:p>
-        </p:txBody>
-      </p:sp>
-      <p:sp>
-        <p:nvSpPr>
-          <p:cNvPr id="21" name="TextBox 20"/>
-          <p:cNvSpPr txBox="1"/>
-          <p:nvPr/>
-        </p:nvSpPr>
-        <p:spPr>
-          <a:xfrm>
-            <a:off x="5047488" y="3931920"/>
-            <a:ext cx="3639312" cy="338554"/>
-          </a:xfrm>
-          <a:prstGeom prst="rect">
-            <a:avLst/>
-          </a:prstGeom>
-          <a:noFill/>
-        </p:spPr>
-        <p:txBody>
-          <a:bodyPr wrap="square" lIns="0" tIns="0" rIns="0" bIns="0" anchor="t">
-            <a:spAutoFit/>
-          </a:bodyPr>
-          <a:lstStyle/>
-          <a:p>
-            <a:r>
-              <a:rPr sz="1150" b="1" i="0">
-                <a:solidFill>
-                  <a:srgbClr val="0C1E36"/>
-                </a:solidFill>
-                <a:latin typeface="Times New Roman" panose="02020603050405020304" pitchFamily="18" charset="0"/>
-                <a:cs typeface="Times New Roman" panose="02020603050405020304" pitchFamily="18" charset="0"/>
-              </a:rPr>
-              <a:t>Update Daily  —  </a:t>
-            </a:r>
-            <a:r>
-              <a:rPr sz="1050" b="0" i="0">
-                <a:solidFill>
-                  <a:srgbClr val="333333"/>
-                </a:solidFill>
-                <a:latin typeface="Times New Roman" panose="02020603050405020304" pitchFamily="18" charset="0"/>
-                <a:cs typeface="Times New Roman" panose="02020603050405020304" pitchFamily="18" charset="0"/>
-              </a:rPr>
-              <a:t>Fetches new NAVs since last run, appends to fact_nav, audits in etl_metadata.</a:t>
-            </a:r>
-          </a:p>
-        </p:txBody>
-      </p:sp>
-      <p:sp>
-        <p:nvSpPr>
-          <p:cNvPr id="22" name="TextBox 21"/>
-          <p:cNvSpPr txBox="1"/>
-          <p:nvPr/>
-        </p:nvSpPr>
-        <p:spPr>
-          <a:xfrm>
-            <a:off x="8686800" y="4864608"/>
-            <a:ext cx="365760" cy="138499"/>
-          </a:xfrm>
-          <a:prstGeom prst="rect">
-            <a:avLst/>
-          </a:prstGeom>
-          <a:noFill/>
-        </p:spPr>
-        <p:txBody>
-          <a:bodyPr wrap="square" lIns="0" tIns="0" rIns="0" bIns="0" anchor="t">
-            <a:spAutoFit/>
-          </a:bodyPr>
-          <a:lstStyle/>
-          <a:p>
-            <a:pPr algn="r"/>
-            <a:r>
-              <a:rPr sz="900" b="0" i="0">
-                <a:solidFill>
-                  <a:srgbClr val="8A93A3"/>
-                </a:solidFill>
-                <a:latin typeface="Times New Roman" panose="02020603050405020304" pitchFamily="18" charset="0"/>
-                <a:cs typeface="Times New Roman" panose="02020603050405020304" pitchFamily="18" charset="0"/>
-              </a:rPr>
-              <a:t>6</a:t>
-            </a:r>
-          </a:p>
-        </p:txBody>
-      </p:sp>
-      <p:sp>
-        <p:nvSpPr>
-          <p:cNvPr id="23" name="TextBox 22"/>
-          <p:cNvSpPr txBox="1"/>
-          <p:nvPr/>
-        </p:nvSpPr>
-        <p:spPr>
-          <a:xfrm>
-            <a:off x="457200" y="4864608"/>
-            <a:ext cx="5486400" cy="138499"/>
-          </a:xfrm>
-          <a:prstGeom prst="rect">
-            <a:avLst/>
-          </a:prstGeom>
-          <a:noFill/>
-        </p:spPr>
-        <p:txBody>
-          <a:bodyPr wrap="square" lIns="0" tIns="0" rIns="0" bIns="0" anchor="t">
-            <a:spAutoFit/>
-          </a:bodyPr>
-          <a:lstStyle/>
-          <a:p>
-            <a:r>
-              <a:rPr sz="900" b="0" i="0">
-                <a:solidFill>
-                  <a:srgbClr val="8A93A3"/>
-                </a:solidFill>
-                <a:latin typeface="Times New Roman" panose="02020603050405020304" pitchFamily="18" charset="0"/>
-                <a:cs typeface="Times New Roman" panose="02020603050405020304" pitchFamily="18" charset="0"/>
-              </a:rPr>
-              <a:t>BlueStock Fintech | Mutual Fund Analytics Platform</a:t>
-            </a:r>
-          </a:p>
-        </p:txBody>
-      </p:sp>
-      <p:sp>
-        <p:nvSpPr>
-          <p:cNvPr id="25" name="TextBox 24">
-            <a:extLst>
-              <a:ext uri="{FF2B5EF4-FFF2-40B4-BE49-F238E27FC236}">
-                <a16:creationId xmlns:a16="http://schemas.microsoft.com/office/drawing/2014/main" id="{16E575E9-D755-49B9-032E-8D113EC4CE75}"/>
-              </a:ext>
-            </a:extLst>
-          </p:cNvPr>
-          <p:cNvSpPr txBox="1"/>
-          <p:nvPr/>
-        </p:nvSpPr>
-        <p:spPr>
-          <a:xfrm>
-            <a:off x="457200" y="3767709"/>
-            <a:ext cx="4114800" cy="1056700"/>
-          </a:xfrm>
-          <a:prstGeom prst="rect">
-            <a:avLst/>
-          </a:prstGeom>
-          <a:noFill/>
-        </p:spPr>
-        <p:txBody>
-          <a:bodyPr wrap="square" lIns="0" tIns="0" rIns="0" bIns="0" anchor="t">
-            <a:spAutoFit/>
-          </a:bodyPr>
-          <a:lstStyle/>
-          <a:p>
-            <a:r>
-              <a:rPr lang="en-IN" sz="1200" b="1" i="0">
-                <a:solidFill>
-                  <a:srgbClr val="F58220"/>
-                </a:solidFill>
-                <a:latin typeface="Times New Roman" panose="02020603050405020304" pitchFamily="18" charset="0"/>
-                <a:cs typeface="Times New Roman" panose="02020603050405020304" pitchFamily="18" charset="0"/>
-              </a:rPr>
-              <a:t>fact_transactions</a:t>
-            </a:r>
-            <a:endParaRPr sz="1200" b="1" i="0">
-              <a:solidFill>
-                <a:srgbClr val="F58220"/>
-              </a:solidFill>
-              <a:latin typeface="Times New Roman" panose="02020603050405020304" pitchFamily="18" charset="0"/>
-              <a:cs typeface="Times New Roman" panose="02020603050405020304" pitchFamily="18" charset="0"/>
-            </a:endParaRPr>
-          </a:p>
-          <a:p>
-            <a:pPr>
-              <a:spcBef>
-                <a:spcPts val="100"/>
-              </a:spcBef>
-            </a:pPr>
-            <a:r>
-              <a:rPr lang="en-US" sz="1050"/>
-              <a:t>Tracks investor buy/sell orders and demographics (~32,000 rows).</a:t>
-            </a:r>
-            <a:endParaRPr lang="en-US" sz="800">
-              <a:solidFill>
-                <a:srgbClr val="333333"/>
-              </a:solidFill>
-              <a:latin typeface="Times New Roman" panose="02020603050405020304" pitchFamily="18" charset="0"/>
-              <a:cs typeface="Times New Roman" panose="02020603050405020304" pitchFamily="18" charset="0"/>
-            </a:endParaRPr>
-          </a:p>
-          <a:p>
-            <a:pPr>
-              <a:spcBef>
-                <a:spcPts val="100"/>
-              </a:spcBef>
-            </a:pPr>
-            <a:endParaRPr lang="en-IN" sz="1050" b="0" i="0">
-              <a:solidFill>
-                <a:srgbClr val="333333"/>
-              </a:solidFill>
-              <a:latin typeface="Times New Roman" panose="02020603050405020304" pitchFamily="18" charset="0"/>
-              <a:cs typeface="Times New Roman" panose="02020603050405020304" pitchFamily="18" charset="0"/>
-            </a:endParaRPr>
-          </a:p>
-          <a:p>
-            <a:pPr>
-              <a:spcBef>
-                <a:spcPts val="100"/>
-              </a:spcBef>
-            </a:pPr>
-            <a:endParaRPr lang="en-IN" sz="1050">
-              <a:solidFill>
-                <a:srgbClr val="333333"/>
-              </a:solidFill>
-              <a:latin typeface="Times New Roman" panose="02020603050405020304" pitchFamily="18" charset="0"/>
-              <a:cs typeface="Times New Roman" panose="02020603050405020304" pitchFamily="18" charset="0"/>
-            </a:endParaRPr>
-          </a:p>
-          <a:p>
-            <a:pPr>
-              <a:spcBef>
-                <a:spcPts val="100"/>
-              </a:spcBef>
-            </a:pPr>
-            <a:endParaRPr lang="en-IN" sz="1050" b="0" i="0">
-              <a:solidFill>
-                <a:srgbClr val="333333"/>
-              </a:solidFill>
-              <a:latin typeface="Times New Roman" panose="02020603050405020304" pitchFamily="18" charset="0"/>
-              <a:cs typeface="Times New Roman" panose="02020603050405020304" pitchFamily="18" charset="0"/>
-            </a:endParaRPr>
-          </a:p>
-          <a:p>
-            <a:pPr>
-              <a:spcBef>
-                <a:spcPts val="100"/>
-              </a:spcBef>
-            </a:pPr>
-            <a:endParaRPr sz="1050" b="0" i="0">
-              <a:solidFill>
-                <a:srgbClr val="333333"/>
-              </a:solidFill>
-              <a:latin typeface="Times New Roman" panose="02020603050405020304" pitchFamily="18" charset="0"/>
-              <a:cs typeface="Times New Roman" panose="02020603050405020304" pitchFamily="18" charset="0"/>
-            </a:endParaRPr>
-          </a:p>
-        </p:txBody>
-      </p:sp>
-    </p:spTree>
-  </p:cSld>
-  <p:clrMapOvr>
-    <a:masterClrMapping/>
-  </p:clrMapOvr>
-</p:sld>
-</file>
-
-<file path=ppt/slides/slide7.xml><?xml version="1.0" encoding="utf-8"?>
-<p:sld xmlns:a="http://schemas.openxmlformats.org/drawingml/2006/main" xmlns:r="http://schemas.openxmlformats.org/officeDocument/2006/relationships" xmlns:p="http://schemas.openxmlformats.org/presentationml/2006/main">
-  <p:cSld>
-    <p:spTree>
-      <p:nvGrpSpPr>
-        <p:cNvPr id="1" name=""/>
-        <p:cNvGrpSpPr/>
-        <p:nvPr/>
-      </p:nvGrpSpPr>
-      <p:grpSpPr>
-        <a:xfrm>
-          <a:off x="0" y="0"/>
-          <a:ext cx="0" cy="0"/>
-          <a:chOff x="0" y="0"/>
-          <a:chExt cx="0" cy="0"/>
-        </a:xfrm>
-      </p:grpSpPr>
-      <p:sp>
-        <p:nvSpPr>
-          <p:cNvPr id="4" name="Text 0">
-            <a:extLst>
-              <a:ext uri="{FF2B5EF4-FFF2-40B4-BE49-F238E27FC236}">
-                <a16:creationId xmlns:a16="http://schemas.microsoft.com/office/drawing/2014/main" id="{F96DF72A-1F88-84BA-4DB3-0279FD6D7476}"/>
-              </a:ext>
-            </a:extLst>
-          </p:cNvPr>
-          <p:cNvSpPr/>
-          <p:nvPr/>
-        </p:nvSpPr>
-        <p:spPr>
-          <a:xfrm>
-            <a:off x="283779" y="196596"/>
-            <a:ext cx="5344510" cy="502920"/>
-          </a:xfrm>
-          <a:prstGeom prst="rect">
-            <a:avLst/>
-          </a:prstGeom>
-          <a:noFill/>
-          <a:ln/>
-        </p:spPr>
-        <p:txBody>
-          <a:bodyPr wrap="square" lIns="0" tIns="0" rIns="0" bIns="0" rtlCol="0" anchor="ctr"/>
-          <a:lstStyle/>
-          <a:p>
-            <a:pPr marL="0" indent="0">
-              <a:buNone/>
-            </a:pPr>
-            <a:r>
-              <a:rPr lang="en-US" sz="2400" b="1" dirty="0">
-                <a:solidFill>
-                  <a:srgbClr val="0C1E36"/>
-                </a:solidFill>
-                <a:latin typeface="Times New Roman" pitchFamily="34" charset="0"/>
-                <a:ea typeface="Times New Roman" pitchFamily="34" charset="-122"/>
-                <a:cs typeface="Times New Roman" pitchFamily="34" charset="-120"/>
-              </a:rPr>
-              <a:t>Database Schema — Data Dictionary</a:t>
-            </a:r>
-            <a:endParaRPr lang="en-US" sz="2400" dirty="0"/>
-          </a:p>
-        </p:txBody>
-      </p:sp>
       <p:sp>
         <p:nvSpPr>
           <p:cNvPr id="6" name="Text 2">
@@ -16875,6 +15669,54 @@
           </a:graphicData>
         </a:graphic>
       </p:graphicFrame>
+      <p:sp>
+        <p:nvSpPr>
+          <p:cNvPr id="3" name="TextBox 2">
+            <a:extLst>
+              <a:ext uri="{FF2B5EF4-FFF2-40B4-BE49-F238E27FC236}">
+                <a16:creationId xmlns:a16="http://schemas.microsoft.com/office/drawing/2014/main" id="{E7FE3E53-5A45-6AE4-6E77-009858878EB8}"/>
+              </a:ext>
+            </a:extLst>
+          </p:cNvPr>
+          <p:cNvSpPr txBox="1"/>
+          <p:nvPr/>
+        </p:nvSpPr>
+        <p:spPr>
+          <a:xfrm>
+            <a:off x="305851" y="171244"/>
+            <a:ext cx="8229600" cy="369332"/>
+          </a:xfrm>
+          <a:prstGeom prst="rect">
+            <a:avLst/>
+          </a:prstGeom>
+          <a:noFill/>
+        </p:spPr>
+        <p:txBody>
+          <a:bodyPr wrap="square" lIns="0" tIns="0" rIns="0" bIns="0" anchor="t">
+            <a:spAutoFit/>
+          </a:bodyPr>
+          <a:lstStyle/>
+          <a:p>
+            <a:r>
+              <a:rPr lang="en-IN" sz="2400" b="1" i="0">
+                <a:solidFill>
+                  <a:srgbClr val="0C1E36"/>
+                </a:solidFill>
+                <a:latin typeface="Times New Roman" panose="02020603050405020304" pitchFamily="18" charset="0"/>
+                <a:cs typeface="Times New Roman" panose="02020603050405020304" pitchFamily="18" charset="0"/>
+              </a:rPr>
+              <a:t>Database Design</a:t>
+            </a:r>
+            <a:endParaRPr sz="2400" b="1" i="0">
+              <a:solidFill>
+                <a:srgbClr val="0C1E36"/>
+              </a:solidFill>
+              <a:latin typeface="Times New Roman" panose="02020603050405020304" pitchFamily="18" charset="0"/>
+              <a:cs typeface="Times New Roman" panose="02020603050405020304" pitchFamily="18" charset="0"/>
+            </a:endParaRPr>
+          </a:p>
+        </p:txBody>
+      </p:sp>
     </p:spTree>
     <p:extLst>
       <p:ext uri="{BB962C8B-B14F-4D97-AF65-F5344CB8AC3E}">
@@ -16888,7 +15730,7 @@
 </p:sld>
 </file>
 
-<file path=ppt/slides/slide8.xml><?xml version="1.0" encoding="utf-8"?>
+<file path=ppt/slides/slide7.xml><?xml version="1.0" encoding="utf-8"?>
 <p:sld xmlns:a="http://schemas.openxmlformats.org/drawingml/2006/main" xmlns:r="http://schemas.openxmlformats.org/officeDocument/2006/relationships" xmlns:p="http://schemas.openxmlformats.org/presentationml/2006/main">
   <p:cSld>
     <p:spTree>
@@ -17952,7 +16794,7 @@
 </p:sld>
 </file>
 
-<file path=ppt/slides/slide9.xml><?xml version="1.0" encoding="utf-8"?>
+<file path=ppt/slides/slide8.xml><?xml version="1.0" encoding="utf-8"?>
 <p:sld xmlns:a="http://schemas.openxmlformats.org/drawingml/2006/main" xmlns:r="http://schemas.openxmlformats.org/officeDocument/2006/relationships" xmlns:p="http://schemas.openxmlformats.org/presentationml/2006/main">
   <p:cSld>
     <p:spTree>
@@ -19227,6 +18069,754 @@
 </p:sld>
 </file>
 
+<file path=ppt/slides/slide9.xml><?xml version="1.0" encoding="utf-8"?>
+<p:sld xmlns:a="http://schemas.openxmlformats.org/drawingml/2006/main" xmlns:r="http://schemas.openxmlformats.org/officeDocument/2006/relationships" xmlns:p="http://schemas.openxmlformats.org/presentationml/2006/main">
+  <p:cSld>
+    <p:spTree>
+      <p:nvGrpSpPr>
+        <p:cNvPr id="1" name=""/>
+        <p:cNvGrpSpPr/>
+        <p:nvPr/>
+      </p:nvGrpSpPr>
+      <p:grpSpPr>
+        <a:xfrm>
+          <a:off x="0" y="0"/>
+          <a:ext cx="0" cy="0"/>
+          <a:chOff x="0" y="0"/>
+          <a:chExt cx="0" cy="0"/>
+        </a:xfrm>
+      </p:grpSpPr>
+      <p:sp>
+        <p:nvSpPr>
+          <p:cNvPr id="3" name="TextBox 2"/>
+          <p:cNvSpPr txBox="1"/>
+          <p:nvPr/>
+        </p:nvSpPr>
+        <p:spPr>
+          <a:xfrm>
+            <a:off x="457200" y="179582"/>
+            <a:ext cx="5486400" cy="169277"/>
+          </a:xfrm>
+          <a:prstGeom prst="rect">
+            <a:avLst/>
+          </a:prstGeom>
+          <a:noFill/>
+        </p:spPr>
+        <p:txBody>
+          <a:bodyPr wrap="square" lIns="0" tIns="0" rIns="0" bIns="0" anchor="t">
+            <a:spAutoFit/>
+          </a:bodyPr>
+          <a:lstStyle/>
+          <a:p>
+            <a:r>
+              <a:rPr sz="1100" b="1" i="0" spc="150">
+                <a:solidFill>
+                  <a:srgbClr val="F58220"/>
+                </a:solidFill>
+                <a:latin typeface="Times New Roman" panose="02020603050405020304" pitchFamily="18" charset="0"/>
+                <a:cs typeface="Times New Roman" panose="02020603050405020304" pitchFamily="18" charset="0"/>
+              </a:rPr>
+              <a:t>ARCHITECTURE</a:t>
+            </a:r>
+          </a:p>
+        </p:txBody>
+      </p:sp>
+      <p:sp>
+        <p:nvSpPr>
+          <p:cNvPr id="4" name="TextBox 3"/>
+          <p:cNvSpPr txBox="1"/>
+          <p:nvPr/>
+        </p:nvSpPr>
+        <p:spPr>
+          <a:xfrm>
+            <a:off x="457200" y="422150"/>
+            <a:ext cx="8229600" cy="369332"/>
+          </a:xfrm>
+          <a:prstGeom prst="rect">
+            <a:avLst/>
+          </a:prstGeom>
+          <a:noFill/>
+        </p:spPr>
+        <p:txBody>
+          <a:bodyPr wrap="square" lIns="0" tIns="0" rIns="0" bIns="0" anchor="t">
+            <a:spAutoFit/>
+          </a:bodyPr>
+          <a:lstStyle/>
+          <a:p>
+            <a:r>
+              <a:rPr lang="en-IN" sz="2400" b="1" i="0">
+                <a:solidFill>
+                  <a:srgbClr val="0C1E36"/>
+                </a:solidFill>
+                <a:latin typeface="Times New Roman" panose="02020603050405020304" pitchFamily="18" charset="0"/>
+                <a:cs typeface="Times New Roman" panose="02020603050405020304" pitchFamily="18" charset="0"/>
+              </a:rPr>
+              <a:t>Database Design &amp;</a:t>
+            </a:r>
+            <a:r>
+              <a:rPr sz="2400" b="1" i="0">
+                <a:solidFill>
+                  <a:srgbClr val="0C1E36"/>
+                </a:solidFill>
+                <a:latin typeface="Times New Roman" panose="02020603050405020304" pitchFamily="18" charset="0"/>
+                <a:cs typeface="Times New Roman" panose="02020603050405020304" pitchFamily="18" charset="0"/>
+              </a:rPr>
+              <a:t> ETL Pipeline</a:t>
+            </a:r>
+          </a:p>
+        </p:txBody>
+      </p:sp>
+      <p:grpSp>
+        <p:nvGrpSpPr>
+          <p:cNvPr id="26" name="Group 25">
+            <a:extLst>
+              <a:ext uri="{FF2B5EF4-FFF2-40B4-BE49-F238E27FC236}">
+                <a16:creationId xmlns:a16="http://schemas.microsoft.com/office/drawing/2014/main" id="{00741A42-797B-3449-1E39-4034DD645B2D}"/>
+              </a:ext>
+            </a:extLst>
+          </p:cNvPr>
+          <p:cNvGrpSpPr/>
+          <p:nvPr/>
+        </p:nvGrpSpPr>
+        <p:grpSpPr>
+          <a:xfrm>
+            <a:off x="961697" y="1013872"/>
+            <a:ext cx="7094482" cy="3680463"/>
+            <a:chOff x="4709160" y="1325880"/>
+            <a:chExt cx="3977640" cy="2979818"/>
+          </a:xfrm>
+        </p:grpSpPr>
+        <p:sp>
+          <p:nvSpPr>
+            <p:cNvPr id="16" name="Oval 15"/>
+            <p:cNvSpPr/>
+            <p:nvPr/>
+          </p:nvSpPr>
+          <p:spPr>
+            <a:xfrm>
+              <a:off x="4709160" y="2843784"/>
+              <a:ext cx="201168" cy="201168"/>
+            </a:xfrm>
+            <a:prstGeom prst="ellipse">
+              <a:avLst/>
+            </a:prstGeom>
+            <a:solidFill>
+              <a:srgbClr val="0C1E36"/>
+            </a:solidFill>
+            <a:ln>
+              <a:noFill/>
+            </a:ln>
+            <a:effectLst/>
+          </p:spPr>
+          <p:style>
+            <a:lnRef idx="1">
+              <a:schemeClr val="accent1"/>
+            </a:lnRef>
+            <a:fillRef idx="3">
+              <a:schemeClr val="accent1"/>
+            </a:fillRef>
+            <a:effectRef idx="2">
+              <a:schemeClr val="accent1"/>
+            </a:effectRef>
+            <a:fontRef idx="minor">
+              <a:schemeClr val="lt1"/>
+            </a:fontRef>
+          </p:style>
+          <p:txBody>
+            <a:bodyPr lIns="0" tIns="0" rIns="0" bIns="0" rtlCol="0" anchor="ctr"/>
+            <a:lstStyle/>
+            <a:p>
+              <a:pPr algn="ctr"/>
+              <a:r>
+                <a:rPr sz="900" b="1" i="0">
+                  <a:solidFill>
+                    <a:srgbClr val="FFFFFF"/>
+                  </a:solidFill>
+                  <a:latin typeface="Times New Roman" panose="02020603050405020304" pitchFamily="18" charset="0"/>
+                  <a:cs typeface="Times New Roman" panose="02020603050405020304" pitchFamily="18" charset="0"/>
+                </a:rPr>
+                <a:t>3</a:t>
+              </a:r>
+            </a:p>
+          </p:txBody>
+        </p:sp>
+        <p:grpSp>
+          <p:nvGrpSpPr>
+            <p:cNvPr id="24" name="Group 23">
+              <a:extLst>
+                <a:ext uri="{FF2B5EF4-FFF2-40B4-BE49-F238E27FC236}">
+                  <a16:creationId xmlns:a16="http://schemas.microsoft.com/office/drawing/2014/main" id="{1B33DBD3-535D-0A7F-20ED-EAB0E1C78184}"/>
+                </a:ext>
+              </a:extLst>
+            </p:cNvPr>
+            <p:cNvGrpSpPr/>
+            <p:nvPr/>
+          </p:nvGrpSpPr>
+          <p:grpSpPr>
+            <a:xfrm>
+              <a:off x="4709160" y="1325880"/>
+              <a:ext cx="3977640" cy="2979818"/>
+              <a:chOff x="4709160" y="1325880"/>
+              <a:chExt cx="3977640" cy="2979818"/>
+            </a:xfrm>
+          </p:grpSpPr>
+          <p:sp>
+            <p:nvSpPr>
+              <p:cNvPr id="11" name="TextBox 10"/>
+              <p:cNvSpPr txBox="1"/>
+              <p:nvPr/>
+            </p:nvSpPr>
+            <p:spPr>
+              <a:xfrm>
+                <a:off x="4709160" y="1325880"/>
+                <a:ext cx="3977639" cy="199348"/>
+              </a:xfrm>
+              <a:prstGeom prst="rect">
+                <a:avLst/>
+              </a:prstGeom>
+              <a:noFill/>
+            </p:spPr>
+            <p:txBody>
+              <a:bodyPr wrap="square" lIns="0" tIns="0" rIns="0" bIns="0" anchor="t">
+                <a:spAutoFit/>
+              </a:bodyPr>
+              <a:lstStyle/>
+              <a:p>
+                <a:r>
+                  <a:rPr sz="1600" b="1" i="0">
+                    <a:solidFill>
+                      <a:srgbClr val="0C1E36"/>
+                    </a:solidFill>
+                    <a:latin typeface="Times New Roman" panose="02020603050405020304" pitchFamily="18" charset="0"/>
+                    <a:cs typeface="Times New Roman" panose="02020603050405020304" pitchFamily="18" charset="0"/>
+                  </a:rPr>
+                  <a:t>ETL Workflow</a:t>
+                </a:r>
+              </a:p>
+            </p:txBody>
+          </p:sp>
+          <p:sp>
+            <p:nvSpPr>
+              <p:cNvPr id="12" name="Oval 11"/>
+              <p:cNvSpPr/>
+              <p:nvPr/>
+            </p:nvSpPr>
+            <p:spPr>
+              <a:xfrm>
+                <a:off x="4709160" y="1709928"/>
+                <a:ext cx="201168" cy="201168"/>
+              </a:xfrm>
+              <a:prstGeom prst="ellipse">
+                <a:avLst/>
+              </a:prstGeom>
+              <a:solidFill>
+                <a:srgbClr val="0C1E36"/>
+              </a:solidFill>
+              <a:ln>
+                <a:noFill/>
+              </a:ln>
+              <a:effectLst/>
+            </p:spPr>
+            <p:style>
+              <a:lnRef idx="1">
+                <a:schemeClr val="accent1"/>
+              </a:lnRef>
+              <a:fillRef idx="3">
+                <a:schemeClr val="accent1"/>
+              </a:fillRef>
+              <a:effectRef idx="2">
+                <a:schemeClr val="accent1"/>
+              </a:effectRef>
+              <a:fontRef idx="minor">
+                <a:schemeClr val="lt1"/>
+              </a:fontRef>
+            </p:style>
+            <p:txBody>
+              <a:bodyPr lIns="0" tIns="0" rIns="0" bIns="0" rtlCol="0" anchor="ctr"/>
+              <a:lstStyle/>
+              <a:p>
+                <a:pPr algn="ctr"/>
+                <a:r>
+                  <a:rPr sz="900" b="1" i="0">
+                    <a:solidFill>
+                      <a:srgbClr val="FFFFFF"/>
+                    </a:solidFill>
+                    <a:latin typeface="Times New Roman" panose="02020603050405020304" pitchFamily="18" charset="0"/>
+                    <a:cs typeface="Times New Roman" panose="02020603050405020304" pitchFamily="18" charset="0"/>
+                  </a:rPr>
+                  <a:t>1</a:t>
+                </a:r>
+              </a:p>
+            </p:txBody>
+          </p:sp>
+          <p:sp>
+            <p:nvSpPr>
+              <p:cNvPr id="13" name="TextBox 12"/>
+              <p:cNvSpPr txBox="1"/>
+              <p:nvPr/>
+            </p:nvSpPr>
+            <p:spPr>
+              <a:xfrm>
+                <a:off x="5047488" y="1664208"/>
+                <a:ext cx="3639312" cy="373779"/>
+              </a:xfrm>
+              <a:prstGeom prst="rect">
+                <a:avLst/>
+              </a:prstGeom>
+              <a:noFill/>
+            </p:spPr>
+            <p:txBody>
+              <a:bodyPr wrap="square" lIns="0" tIns="0" rIns="0" bIns="0" anchor="t">
+                <a:spAutoFit/>
+              </a:bodyPr>
+              <a:lstStyle/>
+              <a:p>
+                <a:r>
+                  <a:rPr sz="1600" b="1" i="0">
+                    <a:solidFill>
+                      <a:srgbClr val="0C1E36"/>
+                    </a:solidFill>
+                    <a:latin typeface="Times New Roman" panose="02020603050405020304" pitchFamily="18" charset="0"/>
+                    <a:cs typeface="Times New Roman" panose="02020603050405020304" pitchFamily="18" charset="0"/>
+                  </a:rPr>
+                  <a:t>Extract  —  </a:t>
+                </a:r>
+                <a:r>
+                  <a:rPr sz="1400" b="0" i="0">
+                    <a:solidFill>
+                      <a:srgbClr val="333333"/>
+                    </a:solidFill>
+                    <a:latin typeface="Times New Roman" panose="02020603050405020304" pitchFamily="18" charset="0"/>
+                    <a:cs typeface="Times New Roman" panose="02020603050405020304" pitchFamily="18" charset="0"/>
+                  </a:rPr>
+                  <a:t>Reads raw CSVs and queries AMFI / MFAPI APIs for live historical NAV data.</a:t>
+                </a:r>
+              </a:p>
+            </p:txBody>
+          </p:sp>
+          <p:sp>
+            <p:nvSpPr>
+              <p:cNvPr id="14" name="Oval 13"/>
+              <p:cNvSpPr/>
+              <p:nvPr/>
+            </p:nvSpPr>
+            <p:spPr>
+              <a:xfrm>
+                <a:off x="4709160" y="2276856"/>
+                <a:ext cx="201168" cy="201168"/>
+              </a:xfrm>
+              <a:prstGeom prst="ellipse">
+                <a:avLst/>
+              </a:prstGeom>
+              <a:solidFill>
+                <a:srgbClr val="0C1E36"/>
+              </a:solidFill>
+              <a:ln>
+                <a:noFill/>
+              </a:ln>
+              <a:effectLst/>
+            </p:spPr>
+            <p:style>
+              <a:lnRef idx="1">
+                <a:schemeClr val="accent1"/>
+              </a:lnRef>
+              <a:fillRef idx="3">
+                <a:schemeClr val="accent1"/>
+              </a:fillRef>
+              <a:effectRef idx="2">
+                <a:schemeClr val="accent1"/>
+              </a:effectRef>
+              <a:fontRef idx="minor">
+                <a:schemeClr val="lt1"/>
+              </a:fontRef>
+            </p:style>
+            <p:txBody>
+              <a:bodyPr lIns="0" tIns="0" rIns="0" bIns="0" rtlCol="0" anchor="ctr"/>
+              <a:lstStyle/>
+              <a:p>
+                <a:pPr algn="ctr"/>
+                <a:r>
+                  <a:rPr sz="900" b="1" i="0">
+                    <a:solidFill>
+                      <a:srgbClr val="FFFFFF"/>
+                    </a:solidFill>
+                    <a:latin typeface="Times New Roman" panose="02020603050405020304" pitchFamily="18" charset="0"/>
+                    <a:cs typeface="Times New Roman" panose="02020603050405020304" pitchFamily="18" charset="0"/>
+                  </a:rPr>
+                  <a:t>2</a:t>
+                </a:r>
+              </a:p>
+            </p:txBody>
+          </p:sp>
+          <p:sp>
+            <p:nvSpPr>
+              <p:cNvPr id="15" name="TextBox 14"/>
+              <p:cNvSpPr txBox="1"/>
+              <p:nvPr/>
+            </p:nvSpPr>
+            <p:spPr>
+              <a:xfrm>
+                <a:off x="5047488" y="2231136"/>
+                <a:ext cx="3639312" cy="373779"/>
+              </a:xfrm>
+              <a:prstGeom prst="rect">
+                <a:avLst/>
+              </a:prstGeom>
+              <a:noFill/>
+            </p:spPr>
+            <p:txBody>
+              <a:bodyPr wrap="square" lIns="0" tIns="0" rIns="0" bIns="0" anchor="t">
+                <a:spAutoFit/>
+              </a:bodyPr>
+              <a:lstStyle/>
+              <a:p>
+                <a:r>
+                  <a:rPr sz="1600" b="1" i="0">
+                    <a:solidFill>
+                      <a:srgbClr val="0C1E36"/>
+                    </a:solidFill>
+                    <a:latin typeface="Times New Roman" panose="02020603050405020304" pitchFamily="18" charset="0"/>
+                    <a:cs typeface="Times New Roman" panose="02020603050405020304" pitchFamily="18" charset="0"/>
+                  </a:rPr>
+                  <a:t>Transform  —  </a:t>
+                </a:r>
+                <a:r>
+                  <a:rPr sz="1400" b="0" i="0">
+                    <a:solidFill>
+                      <a:srgbClr val="333333"/>
+                    </a:solidFill>
+                    <a:latin typeface="Times New Roman" panose="02020603050405020304" pitchFamily="18" charset="0"/>
+                    <a:cs typeface="Times New Roman" panose="02020603050405020304" pitchFamily="18" charset="0"/>
+                  </a:rPr>
+                  <a:t>Standardizes dates, coerces types, removes duplicates, handles missing values.</a:t>
+                </a:r>
+              </a:p>
+            </p:txBody>
+          </p:sp>
+          <p:sp>
+            <p:nvSpPr>
+              <p:cNvPr id="17" name="TextBox 16"/>
+              <p:cNvSpPr txBox="1"/>
+              <p:nvPr/>
+            </p:nvSpPr>
+            <p:spPr>
+              <a:xfrm>
+                <a:off x="5047488" y="2798064"/>
+                <a:ext cx="3639312" cy="373779"/>
+              </a:xfrm>
+              <a:prstGeom prst="rect">
+                <a:avLst/>
+              </a:prstGeom>
+              <a:noFill/>
+            </p:spPr>
+            <p:txBody>
+              <a:bodyPr wrap="square" lIns="0" tIns="0" rIns="0" bIns="0" anchor="t">
+                <a:spAutoFit/>
+              </a:bodyPr>
+              <a:lstStyle/>
+              <a:p>
+                <a:r>
+                  <a:rPr sz="1600" b="1" i="0">
+                    <a:solidFill>
+                      <a:srgbClr val="0C1E36"/>
+                    </a:solidFill>
+                    <a:latin typeface="Times New Roman" panose="02020603050405020304" pitchFamily="18" charset="0"/>
+                    <a:cs typeface="Times New Roman" panose="02020603050405020304" pitchFamily="18" charset="0"/>
+                  </a:rPr>
+                  <a:t>Correct  —  </a:t>
+                </a:r>
+                <a:r>
+                  <a:rPr sz="1400" b="0" i="0">
+                    <a:solidFill>
+                      <a:srgbClr val="333333"/>
+                    </a:solidFill>
+                    <a:latin typeface="Times New Roman" panose="02020603050405020304" pitchFamily="18" charset="0"/>
+                    <a:cs typeface="Times New Roman" panose="02020603050405020304" pitchFamily="18" charset="0"/>
+                  </a:rPr>
+                  <a:t>Fixes AMFI ID mismatches (e.g. ABSL Large Cap 112114 → 103174).</a:t>
+                </a:r>
+              </a:p>
+            </p:txBody>
+          </p:sp>
+          <p:sp>
+            <p:nvSpPr>
+              <p:cNvPr id="18" name="Oval 17"/>
+              <p:cNvSpPr/>
+              <p:nvPr/>
+            </p:nvSpPr>
+            <p:spPr>
+              <a:xfrm>
+                <a:off x="4709160" y="3410712"/>
+                <a:ext cx="201168" cy="201168"/>
+              </a:xfrm>
+              <a:prstGeom prst="ellipse">
+                <a:avLst/>
+              </a:prstGeom>
+              <a:solidFill>
+                <a:srgbClr val="0C1E36"/>
+              </a:solidFill>
+              <a:ln>
+                <a:noFill/>
+              </a:ln>
+              <a:effectLst/>
+            </p:spPr>
+            <p:style>
+              <a:lnRef idx="1">
+                <a:schemeClr val="accent1"/>
+              </a:lnRef>
+              <a:fillRef idx="3">
+                <a:schemeClr val="accent1"/>
+              </a:fillRef>
+              <a:effectRef idx="2">
+                <a:schemeClr val="accent1"/>
+              </a:effectRef>
+              <a:fontRef idx="minor">
+                <a:schemeClr val="lt1"/>
+              </a:fontRef>
+            </p:style>
+            <p:txBody>
+              <a:bodyPr lIns="0" tIns="0" rIns="0" bIns="0" rtlCol="0" anchor="ctr"/>
+              <a:lstStyle/>
+              <a:p>
+                <a:pPr algn="ctr"/>
+                <a:r>
+                  <a:rPr sz="900" b="1" i="0">
+                    <a:solidFill>
+                      <a:srgbClr val="FFFFFF"/>
+                    </a:solidFill>
+                    <a:latin typeface="Times New Roman" panose="02020603050405020304" pitchFamily="18" charset="0"/>
+                    <a:cs typeface="Times New Roman" panose="02020603050405020304" pitchFamily="18" charset="0"/>
+                  </a:rPr>
+                  <a:t>4</a:t>
+                </a:r>
+              </a:p>
+            </p:txBody>
+          </p:sp>
+          <p:sp>
+            <p:nvSpPr>
+              <p:cNvPr id="19" name="TextBox 18"/>
+              <p:cNvSpPr txBox="1"/>
+              <p:nvPr/>
+            </p:nvSpPr>
+            <p:spPr>
+              <a:xfrm>
+                <a:off x="5047488" y="3364992"/>
+                <a:ext cx="3639312" cy="199348"/>
+              </a:xfrm>
+              <a:prstGeom prst="rect">
+                <a:avLst/>
+              </a:prstGeom>
+              <a:noFill/>
+            </p:spPr>
+            <p:txBody>
+              <a:bodyPr wrap="square" lIns="0" tIns="0" rIns="0" bIns="0" anchor="t">
+                <a:spAutoFit/>
+              </a:bodyPr>
+              <a:lstStyle/>
+              <a:p>
+                <a:r>
+                  <a:rPr sz="1600" b="1" i="0">
+                    <a:solidFill>
+                      <a:srgbClr val="0C1E36"/>
+                    </a:solidFill>
+                    <a:latin typeface="Times New Roman" panose="02020603050405020304" pitchFamily="18" charset="0"/>
+                    <a:cs typeface="Times New Roman" panose="02020603050405020304" pitchFamily="18" charset="0"/>
+                  </a:rPr>
+                  <a:t>Load  —  </a:t>
+                </a:r>
+                <a:r>
+                  <a:rPr sz="1400" b="0" i="0">
+                    <a:solidFill>
+                      <a:srgbClr val="333333"/>
+                    </a:solidFill>
+                    <a:latin typeface="Times New Roman" panose="02020603050405020304" pitchFamily="18" charset="0"/>
+                    <a:cs typeface="Times New Roman" panose="02020603050405020304" pitchFamily="18" charset="0"/>
+                  </a:rPr>
+                  <a:t>Loads cleaned staging tables into SQLite with FK &amp; unique constraints.</a:t>
+                </a:r>
+              </a:p>
+            </p:txBody>
+          </p:sp>
+          <p:sp>
+            <p:nvSpPr>
+              <p:cNvPr id="20" name="Oval 19"/>
+              <p:cNvSpPr/>
+              <p:nvPr/>
+            </p:nvSpPr>
+            <p:spPr>
+              <a:xfrm>
+                <a:off x="4709160" y="3977640"/>
+                <a:ext cx="201168" cy="201168"/>
+              </a:xfrm>
+              <a:prstGeom prst="ellipse">
+                <a:avLst/>
+              </a:prstGeom>
+              <a:solidFill>
+                <a:srgbClr val="0C1E36"/>
+              </a:solidFill>
+              <a:ln>
+                <a:noFill/>
+              </a:ln>
+              <a:effectLst/>
+            </p:spPr>
+            <p:style>
+              <a:lnRef idx="1">
+                <a:schemeClr val="accent1"/>
+              </a:lnRef>
+              <a:fillRef idx="3">
+                <a:schemeClr val="accent1"/>
+              </a:fillRef>
+              <a:effectRef idx="2">
+                <a:schemeClr val="accent1"/>
+              </a:effectRef>
+              <a:fontRef idx="minor">
+                <a:schemeClr val="lt1"/>
+              </a:fontRef>
+            </p:style>
+            <p:txBody>
+              <a:bodyPr lIns="0" tIns="0" rIns="0" bIns="0" rtlCol="0" anchor="ctr"/>
+              <a:lstStyle/>
+              <a:p>
+                <a:pPr algn="ctr"/>
+                <a:r>
+                  <a:rPr sz="900" b="1" i="0">
+                    <a:solidFill>
+                      <a:srgbClr val="FFFFFF"/>
+                    </a:solidFill>
+                    <a:latin typeface="Times New Roman" panose="02020603050405020304" pitchFamily="18" charset="0"/>
+                    <a:cs typeface="Times New Roman" panose="02020603050405020304" pitchFamily="18" charset="0"/>
+                  </a:rPr>
+                  <a:t>5</a:t>
+                </a:r>
+              </a:p>
+            </p:txBody>
+          </p:sp>
+          <p:sp>
+            <p:nvSpPr>
+              <p:cNvPr id="21" name="TextBox 20"/>
+              <p:cNvSpPr txBox="1"/>
+              <p:nvPr/>
+            </p:nvSpPr>
+            <p:spPr>
+              <a:xfrm>
+                <a:off x="5047488" y="3931920"/>
+                <a:ext cx="3639312" cy="373778"/>
+              </a:xfrm>
+              <a:prstGeom prst="rect">
+                <a:avLst/>
+              </a:prstGeom>
+              <a:noFill/>
+            </p:spPr>
+            <p:txBody>
+              <a:bodyPr wrap="square" lIns="0" tIns="0" rIns="0" bIns="0" anchor="t">
+                <a:spAutoFit/>
+              </a:bodyPr>
+              <a:lstStyle/>
+              <a:p>
+                <a:r>
+                  <a:rPr sz="1600" b="1" i="0">
+                    <a:solidFill>
+                      <a:srgbClr val="0C1E36"/>
+                    </a:solidFill>
+                    <a:latin typeface="Times New Roman" panose="02020603050405020304" pitchFamily="18" charset="0"/>
+                    <a:cs typeface="Times New Roman" panose="02020603050405020304" pitchFamily="18" charset="0"/>
+                  </a:rPr>
+                  <a:t>Update Daily  —  </a:t>
+                </a:r>
+                <a:r>
+                  <a:rPr sz="1400" b="0" i="0">
+                    <a:solidFill>
+                      <a:srgbClr val="333333"/>
+                    </a:solidFill>
+                    <a:latin typeface="Times New Roman" panose="02020603050405020304" pitchFamily="18" charset="0"/>
+                    <a:cs typeface="Times New Roman" panose="02020603050405020304" pitchFamily="18" charset="0"/>
+                  </a:rPr>
+                  <a:t>Fetches new NAVs since last run, appends to fact_nav, audits in etl_metadata.</a:t>
+                </a:r>
+              </a:p>
+            </p:txBody>
+          </p:sp>
+        </p:grpSp>
+      </p:grpSp>
+      <p:sp>
+        <p:nvSpPr>
+          <p:cNvPr id="22" name="TextBox 21"/>
+          <p:cNvSpPr txBox="1"/>
+          <p:nvPr/>
+        </p:nvSpPr>
+        <p:spPr>
+          <a:xfrm>
+            <a:off x="8686800" y="4864608"/>
+            <a:ext cx="365760" cy="138499"/>
+          </a:xfrm>
+          <a:prstGeom prst="rect">
+            <a:avLst/>
+          </a:prstGeom>
+          <a:noFill/>
+        </p:spPr>
+        <p:txBody>
+          <a:bodyPr wrap="square" lIns="0" tIns="0" rIns="0" bIns="0" anchor="t">
+            <a:spAutoFit/>
+          </a:bodyPr>
+          <a:lstStyle/>
+          <a:p>
+            <a:pPr algn="r"/>
+            <a:r>
+              <a:rPr sz="900" b="0" i="0">
+                <a:solidFill>
+                  <a:srgbClr val="8A93A3"/>
+                </a:solidFill>
+                <a:latin typeface="Times New Roman" panose="02020603050405020304" pitchFamily="18" charset="0"/>
+                <a:cs typeface="Times New Roman" panose="02020603050405020304" pitchFamily="18" charset="0"/>
+              </a:rPr>
+              <a:t>6</a:t>
+            </a:r>
+          </a:p>
+        </p:txBody>
+      </p:sp>
+      <p:sp>
+        <p:nvSpPr>
+          <p:cNvPr id="23" name="TextBox 22"/>
+          <p:cNvSpPr txBox="1"/>
+          <p:nvPr/>
+        </p:nvSpPr>
+        <p:spPr>
+          <a:xfrm>
+            <a:off x="457200" y="4864608"/>
+            <a:ext cx="5486400" cy="138499"/>
+          </a:xfrm>
+          <a:prstGeom prst="rect">
+            <a:avLst/>
+          </a:prstGeom>
+          <a:noFill/>
+        </p:spPr>
+        <p:txBody>
+          <a:bodyPr wrap="square" lIns="0" tIns="0" rIns="0" bIns="0" anchor="t">
+            <a:spAutoFit/>
+          </a:bodyPr>
+          <a:lstStyle/>
+          <a:p>
+            <a:r>
+              <a:rPr sz="900" b="0" i="0">
+                <a:solidFill>
+                  <a:srgbClr val="8A93A3"/>
+                </a:solidFill>
+                <a:latin typeface="Times New Roman" panose="02020603050405020304" pitchFamily="18" charset="0"/>
+                <a:cs typeface="Times New Roman" panose="02020603050405020304" pitchFamily="18" charset="0"/>
+              </a:rPr>
+              <a:t>BlueStock Fintech | Mutual Fund Analytics Platform</a:t>
+            </a:r>
+          </a:p>
+        </p:txBody>
+      </p:sp>
+    </p:spTree>
+  </p:cSld>
+  <p:clrMapOvr>
+    <a:masterClrMapping/>
+  </p:clrMapOvr>
+</p:sld>
+</file>
+
 <file path=ppt/theme/theme1.xml><?xml version="1.0" encoding="utf-8"?>
 <a:theme xmlns:a="http://schemas.openxmlformats.org/drawingml/2006/main" name="Office Theme">
   <a:themeElements>

</xml_diff>